<commit_message>
Correct the spelling of Lana Bakrieh, and two deck fixes found while checking
Her name was written "Bakre" on the title slide, the closing slide, the deck's
author metadata, SUBMISSION.txt and the timing plan. Corrected everywhere.

Two things the re-render showed while checking those two slides:

  - the RESULTS card on the title slide was 0.1" shorter than its own caption,
    so the last line sat on the card border;
  - the closing slide said "Backup slides follow - B1 to B5", but the deck has
    had six backup slides since the perf/QEMU slide was demoted to B6.

Co-Authored-By: Claude Opus 5 <noreply@anthropic.com>
</commit_message>
<xml_diff>
--- a/presentation/HWSW_CoDesign_Final_Taha_Lana.pptx
+++ b/presentation/HWSW_CoDesign_Final_Taha_Lana.pptx
@@ -1406,7 +1406,7 @@
           <a:p>
             <a:r>
               <a:rPr lang="en-US" dirty="0"/>
-              <a:t>Both. 0:05. Stop here - this is the end of the presented material. Leave the slide up for the questions: it carries both headline numbers and the verification count. Everything after it is backup: B1 canonical Huffman, B2 the three interface rules, B3 the measurement environment, B4 what we rejected, B5 testing beyond the benchmark.</a:t>
+              <a:t>Both. 0:05. Stop here - this is the end of the presented material. Leave the slide up for the questions: it carries both headline numbers and the verification count. Everything after it is backup: B1 canonical Huffman, B2 the three interface rules, B3 the measurement environment, B4 what we rejected, B5 testing beyond the benchmark, B6 what perf can and cannot do in the guest.</a:t>
             </a:r>
             <a:endParaRPr lang="en-US" dirty="0"/>
           </a:p>
@@ -3187,7 +3187,7 @@
                 <a:ea typeface="Calibri" pitchFamily="34" charset="-122"/>
                 <a:cs typeface="Calibri" pitchFamily="34" charset="-120"/>
               </a:rPr>
-              <a:t>Taha Taha   ·   Lana Bakre</a:t>
+              <a:t>Taha Taha   ·   Lana Bakrieh</a:t>
             </a:r>
             <a:endParaRPr lang="en-US" sz="1600" dirty="0"/>
           </a:p>
@@ -3241,7 +3241,7 @@
         <p:spPr>
           <a:xfrm>
             <a:off x="8686800" y="1783080"/>
-            <a:ext cx="2971800" cy="3200400"/>
+            <a:ext cx="2971800" cy="3474720"/>
           </a:xfrm>
           <a:prstGeom prst="roundRect">
             <a:avLst>
@@ -12954,7 +12954,7 @@
                 <a:ea typeface="Calibri" pitchFamily="34" charset="-122"/>
                 <a:cs typeface="Calibri" pitchFamily="34" charset="-120"/>
               </a:rPr>
-              <a:t>Taha Taha   ·   Lana Bakre</a:t>
+              <a:t>Taha Taha   ·   Lana Bakrieh</a:t>
             </a:r>
             <a:endParaRPr lang="en-US" sz="1600" dirty="0"/>
           </a:p>
@@ -13440,7 +13440,7 @@
                 <a:ea typeface="Calibri" pitchFamily="34" charset="-122"/>
                 <a:cs typeface="Calibri" pitchFamily="34" charset="-120"/>
               </a:rPr>
-              <a:t>Backup slides follow — B1 to B5</a:t>
+              <a:t>Backup slides follow — B1 to B6</a:t>
             </a:r>
             <a:endParaRPr lang="en-US" sz="1100" dirty="0"/>
           </a:p>

</xml_diff>